<commit_message>
Fix labels for QR codes
</commit_message>
<xml_diff>
--- a/documents/posters/Dahlquist-et-al_Yeast-Genetics_2026.pptx
+++ b/documents/posters/Dahlquist-et-al_Yeast-Genetics_2026.pptx
@@ -17806,7 +17806,7 @@
         <p:spPr>
           <a:xfrm>
             <a:off x="36361470" y="5193635"/>
-            <a:ext cx="1184940" cy="369332"/>
+            <a:ext cx="1146468" cy="369332"/>
           </a:xfrm>
           <a:prstGeom prst="rect">
             <a:avLst/>
@@ -17821,7 +17821,7 @@
           <a:p>
             <a:r>
               <a:rPr lang="en-US" sz="1800" dirty="0" err="1"/>
-              <a:t>GRNsight</a:t>
+              <a:t>GRNmap</a:t>
             </a:r>
             <a:endParaRPr lang="en-US" sz="1800" dirty="0"/>
           </a:p>
@@ -17842,7 +17842,7 @@
         <p:spPr>
           <a:xfrm>
             <a:off x="7084782" y="5193635"/>
-            <a:ext cx="1146468" cy="369332"/>
+            <a:ext cx="1184940" cy="369332"/>
           </a:xfrm>
           <a:prstGeom prst="rect">
             <a:avLst/>
@@ -17857,7 +17857,7 @@
           <a:p>
             <a:r>
               <a:rPr lang="en-US" sz="1800" dirty="0" err="1"/>
-              <a:t>GRNmap</a:t>
+              <a:t>GRNsight</a:t>
             </a:r>
             <a:endParaRPr lang="en-US" sz="1800" dirty="0"/>
           </a:p>

</xml_diff>